<commit_message>
Add Group members names in the PPT
</commit_message>
<xml_diff>
--- a/healthcare_labs_summary.pptx
+++ b/healthcare_labs_summary.pptx
@@ -1673,8 +1673,8 @@
         </p:nvSpPr>
         <p:spPr>
           <a:xfrm>
-            <a:off x="731520" y="5852160"/>
-            <a:ext cx="3657600" cy="365760"/>
+            <a:off x="731519" y="5852160"/>
+            <a:ext cx="6902179" cy="365760"/>
           </a:xfrm>
           <a:prstGeom prst="rect">
             <a:avLst/>
@@ -1698,9 +1698,118 @@
                 <a:ea typeface="Calibri" pitchFamily="34" charset="-122"/>
                 <a:cs typeface="Calibri" pitchFamily="34" charset="-120"/>
               </a:rPr>
-              <a:t>GROUP 3</a:t>
-            </a:r>
-            <a:endParaRPr lang="en-US" sz="1300" dirty="0"/>
+              <a:t>GROUP 3: Allen Lyimo | </a:t>
+            </a:r>
+            <a:r>
+              <a:rPr lang="en-US" sz="1300" b="1" dirty="0" err="1">
+                <a:solidFill>
+                  <a:srgbClr val="FFFFFF"/>
+                </a:solidFill>
+                <a:latin typeface="Calibri" pitchFamily="34" charset="0"/>
+                <a:ea typeface="Calibri" pitchFamily="34" charset="-122"/>
+                <a:cs typeface="Calibri" pitchFamily="34" charset="-120"/>
+              </a:rPr>
+              <a:t>Asina</a:t>
+            </a:r>
+            <a:r>
+              <a:rPr lang="en-US" sz="1300" b="1" dirty="0">
+                <a:solidFill>
+                  <a:srgbClr val="FFFFFF"/>
+                </a:solidFill>
+                <a:latin typeface="Calibri" pitchFamily="34" charset="0"/>
+                <a:ea typeface="Calibri" pitchFamily="34" charset="-122"/>
+                <a:cs typeface="Calibri" pitchFamily="34" charset="-120"/>
+              </a:rPr>
+              <a:t> </a:t>
+            </a:r>
+            <a:r>
+              <a:rPr lang="en-US" sz="1300" b="1" dirty="0" err="1">
+                <a:solidFill>
+                  <a:srgbClr val="FFFFFF"/>
+                </a:solidFill>
+                <a:latin typeface="Calibri" pitchFamily="34" charset="0"/>
+                <a:ea typeface="Calibri" pitchFamily="34" charset="-122"/>
+                <a:cs typeface="Calibri" pitchFamily="34" charset="-120"/>
+              </a:rPr>
+              <a:t>Mchomvu</a:t>
+            </a:r>
+            <a:r>
+              <a:rPr lang="en-US" sz="1300" b="1" dirty="0">
+                <a:solidFill>
+                  <a:srgbClr val="FFFFFF"/>
+                </a:solidFill>
+                <a:latin typeface="Calibri" pitchFamily="34" charset="0"/>
+                <a:ea typeface="Calibri" pitchFamily="34" charset="-122"/>
+                <a:cs typeface="Calibri" pitchFamily="34" charset="-120"/>
+              </a:rPr>
+              <a:t> | Frank </a:t>
+            </a:r>
+            <a:r>
+              <a:rPr lang="en-US" sz="1300" b="1" dirty="0" err="1">
+                <a:solidFill>
+                  <a:srgbClr val="FFFFFF"/>
+                </a:solidFill>
+                <a:latin typeface="Calibri" pitchFamily="34" charset="0"/>
+                <a:ea typeface="Calibri" pitchFamily="34" charset="-122"/>
+                <a:cs typeface="Calibri" pitchFamily="34" charset="-120"/>
+              </a:rPr>
+              <a:t>Mtibili</a:t>
+            </a:r>
+            <a:r>
+              <a:rPr lang="en-US" sz="1300" b="1" dirty="0">
+                <a:solidFill>
+                  <a:srgbClr val="FFFFFF"/>
+                </a:solidFill>
+                <a:latin typeface="Calibri" pitchFamily="34" charset="0"/>
+                <a:ea typeface="Calibri" pitchFamily="34" charset="-122"/>
+                <a:cs typeface="Calibri" pitchFamily="34" charset="-120"/>
+              </a:rPr>
+              <a:t> | </a:t>
+            </a:r>
+            <a:r>
+              <a:rPr lang="en-US" sz="1300" b="1" dirty="0" err="1">
+                <a:solidFill>
+                  <a:srgbClr val="FFFFFF"/>
+                </a:solidFill>
+                <a:latin typeface="Calibri" pitchFamily="34" charset="0"/>
+                <a:ea typeface="Calibri" pitchFamily="34" charset="-122"/>
+                <a:cs typeface="Calibri" pitchFamily="34" charset="-120"/>
+              </a:rPr>
+              <a:t>Claverfred</a:t>
+            </a:r>
+            <a:r>
+              <a:rPr lang="en-US" sz="1300" b="1" dirty="0">
+                <a:solidFill>
+                  <a:srgbClr val="FFFFFF"/>
+                </a:solidFill>
+                <a:latin typeface="Calibri" pitchFamily="34" charset="0"/>
+                <a:ea typeface="Calibri" pitchFamily="34" charset="-122"/>
+                <a:cs typeface="Calibri" pitchFamily="34" charset="-120"/>
+              </a:rPr>
+              <a:t> </a:t>
+            </a:r>
+            <a:r>
+              <a:rPr lang="en-US" sz="1300" b="1" dirty="0" err="1">
+                <a:solidFill>
+                  <a:srgbClr val="FFFFFF"/>
+                </a:solidFill>
+                <a:latin typeface="Calibri" pitchFamily="34" charset="0"/>
+                <a:ea typeface="Calibri" pitchFamily="34" charset="-122"/>
+                <a:cs typeface="Calibri" pitchFamily="34" charset="-120"/>
+              </a:rPr>
+              <a:t>Mhidze</a:t>
+            </a:r>
+            <a:r>
+              <a:rPr lang="en-US" sz="1300" b="1" dirty="0">
+                <a:solidFill>
+                  <a:srgbClr val="FFFFFF"/>
+                </a:solidFill>
+                <a:latin typeface="Calibri" pitchFamily="34" charset="0"/>
+                <a:ea typeface="Calibri" pitchFamily="34" charset="-122"/>
+                <a:cs typeface="Calibri" pitchFamily="34" charset="-120"/>
+              </a:rPr>
+              <a:t> | Kelvin Mwanga </a:t>
+            </a:r>
           </a:p>
         </p:txBody>
       </p:sp>

</xml_diff>